<commit_message>
Per-position loss on 40k sequences with CIs; deck wording on the Mess3 axis scale
</commit_message>
<xml_diff>
--- a/deck/belief_state_geometry.pptx
+++ b/deck/belief_state_geometry.pptx
@@ -537,6 +537,76 @@
 </file>
 
 <file path=ppt/notesSlides/notesSlide2.xml><?xml version="1.0" encoding="utf-8"?>
+<p:notes xmlns:a="http://schemas.openxmlformats.org/drawingml/2006/main" xmlns:p="http://schemas.openxmlformats.org/presentationml/2006/main" xmlns:r="http://schemas.openxmlformats.org/officeDocument/2006/relationships">
+  <p:cSld>
+    <p:spTree>
+      <p:nvGrpSpPr>
+        <p:cNvPr id="1" name=""/>
+        <p:cNvGrpSpPr/>
+        <p:nvPr/>
+      </p:nvGrpSpPr>
+      <p:grpSpPr>
+        <a:xfrm>
+          <a:off x="0" y="0"/>
+          <a:ext cx="0" cy="0"/>
+          <a:chOff x="0" y="0"/>
+          <a:chExt cx="0" cy="0"/>
+        </a:xfrm>
+      </p:grpSpPr>
+      <p:sp>
+        <p:nvSpPr>
+          <p:cNvPr id="2" name="Slide Image Placeholder 1"/>
+          <p:cNvSpPr>
+            <a:spLocks noGrp="1"/>
+          </p:cNvSpPr>
+          <p:nvPr>
+            <p:ph type="sldImg" idx="2"/>
+          </p:nvPr>
+        </p:nvSpPr>
+        <p:spPr/>
+      </p:sp>
+      <p:sp>
+        <p:nvSpPr>
+          <p:cNvPr id="3" name="Notes Placeholder 2"/>
+          <p:cNvSpPr>
+            <a:spLocks noGrp="1"/>
+          </p:cNvSpPr>
+          <p:nvPr>
+            <p:ph type="body" idx="3" sz="quarter"/>
+          </p:nvPr>
+        </p:nvSpPr>
+        <p:spPr/>
+        <p:txBody>
+          <a:bodyPr/>
+          <a:lstStyle/>
+          <a:p>
+            <a:r>
+              <a:t>Mess3 is a weak-evidence process: tracking beliefs buys you almost nothing in loss. That is worth saying out loud, because it foreshadows the control result two slides later.</a:t>
+            </a:r>
+          </a:p>
+        </p:txBody>
+      </p:sp>
+      <p:sp>
+        <p:nvSpPr>
+          <p:cNvPr id="4" name="Slide Number Placeholder 3"/>
+          <p:cNvSpPr>
+            <a:spLocks noGrp="1"/>
+          </p:cNvSpPr>
+          <p:nvPr>
+            <p:ph type="sldNum" idx="5" sz="quarter"/>
+          </p:nvPr>
+        </p:nvSpPr>
+        <p:spPr/>
+      </p:sp>
+    </p:spTree>
+  </p:cSld>
+  <p:clrMapOvr>
+    <a:masterClrMapping/>
+  </p:clrMapOvr>
+</p:notes>
+</file>
+
+<file path=ppt/notesSlides/notesSlide3.xml><?xml version="1.0" encoding="utf-8"?>
 <p:notes xmlns:a="http://schemas.openxmlformats.org/drawingml/2006/main" xmlns:p="http://schemas.openxmlformats.org/presentationml/2006/main" xmlns:r="http://schemas.openxmlformats.org/officeDocument/2006/relationships">
   <p:cSld>
     <p:spTree>
@@ -4534,7 +4604,7 @@
         <p:spPr>
           <a:xfrm>
             <a:off x="640080" y="1143000"/>
-            <a:ext cx="10911535" cy="713232"/>
+            <a:ext cx="10911535" cy="1024128"/>
           </a:xfrm>
           <a:prstGeom prst="rect">
             <a:avLst/>
@@ -4581,7 +4651,26 @@
                 </a:solidFill>
                 <a:latin typeface="Calibri"/>
               </a:rPr>
-              <a:t>•  The per-position curve matches the Bayesian staircase, not just its average.</a:t>
+              <a:t>•  RRXOR also matches the Bayesian staircase position by position, not just on average.</a:t>
+            </a:r>
+          </a:p>
+          <a:p>
+            <a:pPr>
+              <a:lnSpc>
+                <a:spcPct val="115000"/>
+              </a:lnSpc>
+              <a:spcAft>
+                <a:spcPts val="600"/>
+              </a:spcAft>
+            </a:pPr>
+            <a:r>
+              <a:rPr sz="1500" b="0">
+                <a:solidFill>
+                  <a:srgbClr val="000000"/>
+                </a:solidFill>
+                <a:latin typeface="Calibri"/>
+              </a:rPr>
+              <a:t>•  Mind the axis on the Mess3 panel: its entire dynamic range is 0.01 nats, so that curve is mostly sampling noise.</a:t>
             </a:r>
           </a:p>
         </p:txBody>
@@ -4602,8 +4691,8 @@
         </p:blipFill>
         <p:spPr>
           <a:xfrm>
-            <a:off x="2641286" y="2057400"/>
-            <a:ext cx="6909121" cy="4343400"/>
+            <a:off x="2888560" y="2368296"/>
+            <a:ext cx="6414573" cy="4032504"/>
           </a:xfrm>
           <a:prstGeom prst="rect">
             <a:avLst/>

</xml_diff>

<commit_message>
Deck layout: wrapped-line sizing and vertical centring on text slides
</commit_message>
<xml_diff>
--- a/deck/belief_state_geometry.pptx
+++ b/deck/belief_state_geometry.pptx
@@ -3832,8 +3832,8 @@
         </p:nvSpPr>
         <p:spPr>
           <a:xfrm>
-            <a:off x="640080" y="1143000"/>
-            <a:ext cx="10911535" cy="1700784"/>
+            <a:off x="640080" y="1901952"/>
+            <a:ext cx="10911535" cy="2505456"/>
           </a:xfrm>
           <a:prstGeom prst="rect">
             <a:avLst/>
@@ -4027,8 +4027,8 @@
         </p:nvSpPr>
         <p:spPr>
           <a:xfrm>
-            <a:off x="640080" y="1143000"/>
-            <a:ext cx="10911535" cy="2103120"/>
+            <a:off x="640080" y="2048256"/>
+            <a:ext cx="10911535" cy="2212848"/>
           </a:xfrm>
           <a:prstGeom prst="rect">
             <a:avLst/>
@@ -4242,7 +4242,7 @@
         <p:spPr>
           <a:xfrm>
             <a:off x="640080" y="1143000"/>
-            <a:ext cx="10911535" cy="713232"/>
+            <a:ext cx="10911535" cy="640080"/>
           </a:xfrm>
           <a:prstGeom prst="rect">
             <a:avLst/>
@@ -4310,7 +4310,7 @@
         </p:blipFill>
         <p:spPr>
           <a:xfrm>
-            <a:off x="548639" y="2057400"/>
+            <a:off x="548639" y="1984248"/>
             <a:ext cx="11094415" cy="4047437"/>
           </a:xfrm>
           <a:prstGeom prst="rect">
@@ -4423,7 +4423,7 @@
         <p:spPr>
           <a:xfrm>
             <a:off x="640080" y="1143000"/>
-            <a:ext cx="10911535" cy="713232"/>
+            <a:ext cx="10911535" cy="640080"/>
           </a:xfrm>
           <a:prstGeom prst="rect">
             <a:avLst/>
@@ -4491,8 +4491,8 @@
         </p:blipFill>
         <p:spPr>
           <a:xfrm>
-            <a:off x="1959419" y="2057400"/>
-            <a:ext cx="8272857" cy="4343400"/>
+            <a:off x="1889752" y="1984248"/>
+            <a:ext cx="8412189" cy="4416552"/>
           </a:xfrm>
           <a:prstGeom prst="rect">
             <a:avLst/>
@@ -4604,7 +4604,7 @@
         <p:spPr>
           <a:xfrm>
             <a:off x="640080" y="1143000"/>
-            <a:ext cx="10911535" cy="1024128"/>
+            <a:ext cx="10911535" cy="877824"/>
           </a:xfrm>
           <a:prstGeom prst="rect">
             <a:avLst/>
@@ -4691,8 +4691,8 @@
         </p:blipFill>
         <p:spPr>
           <a:xfrm>
-            <a:off x="2888560" y="2368296"/>
-            <a:ext cx="6414573" cy="4032504"/>
+            <a:off x="2772196" y="2221992"/>
+            <a:ext cx="6647302" cy="4178808"/>
           </a:xfrm>
           <a:prstGeom prst="rect">
             <a:avLst/>
@@ -4804,7 +4804,7 @@
         <p:spPr>
           <a:xfrm>
             <a:off x="640080" y="1143000"/>
-            <a:ext cx="10911535" cy="713232"/>
+            <a:ext cx="10911535" cy="640080"/>
           </a:xfrm>
           <a:prstGeom prst="rect">
             <a:avLst/>
@@ -4872,7 +4872,7 @@
         </p:blipFill>
         <p:spPr>
           <a:xfrm>
-            <a:off x="548639" y="2057400"/>
+            <a:off x="548639" y="1984248"/>
             <a:ext cx="11094415" cy="3846063"/>
           </a:xfrm>
           <a:prstGeom prst="rect">
@@ -4985,7 +4985,7 @@
         <p:spPr>
           <a:xfrm>
             <a:off x="640080" y="1143000"/>
-            <a:ext cx="10911535" cy="1024128"/>
+            <a:ext cx="10911535" cy="877824"/>
           </a:xfrm>
           <a:prstGeom prst="rect">
             <a:avLst/>
@@ -5072,8 +5072,8 @@
         </p:blipFill>
         <p:spPr>
           <a:xfrm>
-            <a:off x="2239258" y="2368296"/>
-            <a:ext cx="7713178" cy="4032504"/>
+            <a:off x="2099336" y="2221992"/>
+            <a:ext cx="7993022" cy="4178808"/>
           </a:xfrm>
           <a:prstGeom prst="rect">
             <a:avLst/>
@@ -5185,7 +5185,7 @@
         <p:spPr>
           <a:xfrm>
             <a:off x="640080" y="1143000"/>
-            <a:ext cx="10911535" cy="713232"/>
+            <a:ext cx="10911535" cy="640080"/>
           </a:xfrm>
           <a:prstGeom prst="rect">
             <a:avLst/>
@@ -5253,7 +5253,7 @@
         </p:blipFill>
         <p:spPr>
           <a:xfrm>
-            <a:off x="548639" y="2057400"/>
+            <a:off x="548639" y="1984248"/>
             <a:ext cx="11094415" cy="3846063"/>
           </a:xfrm>
           <a:prstGeom prst="rect">
@@ -5366,7 +5366,7 @@
         <p:spPr>
           <a:xfrm>
             <a:off x="640080" y="1143000"/>
-            <a:ext cx="10911535" cy="713232"/>
+            <a:ext cx="10911535" cy="640080"/>
           </a:xfrm>
           <a:prstGeom prst="rect">
             <a:avLst/>
@@ -5434,8 +5434,8 @@
         </p:blipFill>
         <p:spPr>
           <a:xfrm>
-            <a:off x="2445543" y="2057400"/>
-            <a:ext cx="7300608" cy="4343400"/>
+            <a:off x="2384064" y="1984248"/>
+            <a:ext cx="7423566" cy="4416552"/>
           </a:xfrm>
           <a:prstGeom prst="rect">
             <a:avLst/>

</xml_diff>